<commit_message>
Adiciona link do repositório GitHub ao slide de encerramento
</commit_message>
<xml_diff>
--- a/results/apresentacao_executiva.pptx
+++ b/results/apresentacao_executiva.pptx
@@ -1434,7 +1434,7 @@
           <a:p>
             <a:r>
               <a:rPr lang="en-US" dirty="0"/>
-              <a:t>Encerramento. Diga: 'Como próximos passos, propomos ampliar a base com novas safras, testar o modelo em um piloto real e ajustar os limiares com o retorno dos enólogos. Obrigado.'</a:t>
+              <a:t>Encerramento. Diga: 'Como próximos passos, propomos ampliar a base com novas safras, testar o modelo em um piloto real e ajustar os limiares com o retorno dos enólogos. O repositório completo está linkado no slide. Obrigado.'</a:t>
             </a:r>
             <a:endParaRPr lang="en-US" dirty="0"/>
           </a:p>
@@ -2939,8 +2939,8 @@
         </p:nvSpPr>
         <p:spPr>
           <a:xfrm>
-            <a:off x="1645920" y="5394960"/>
-            <a:ext cx="8897112" cy="457200"/>
+            <a:off x="1645920" y="5074920"/>
+            <a:ext cx="8897112" cy="365760"/>
           </a:xfrm>
           <a:prstGeom prst="rect">
             <a:avLst/>
@@ -2964,7 +2964,7 @@
                 <a:ea typeface="Calibri" pitchFamily="34" charset="-122"/>
                 <a:cs typeface="Calibri" pitchFamily="34" charset="-120"/>
               </a:rPr>
-              <a:t>Código, notebooks e detalhamento técnico completo no repositório do projeto.</a:t>
+              <a:t>Código, notebooks e detalhamento técnico completo no repositório do projeto:</a:t>
             </a:r>
             <a:endParaRPr lang="en-US" sz="1250" dirty="0"/>
           </a:p>
@@ -2972,13 +2972,61 @@
       </p:sp>
       <p:sp>
         <p:nvSpPr>
-          <p:cNvPr id="8" name="Text 5"/>
-          <p:cNvSpPr/>
-          <p:nvPr/>
-        </p:nvSpPr>
-        <p:spPr>
-          <a:xfrm>
-            <a:off x="1645920" y="5852160"/>
+          <p:cNvPr id="8" name="Text 5">
+            <a:hlinkClick r:id="rId2" tooltip=""/>
+          </p:cNvPr>
+          <p:cNvSpPr/>
+          <p:nvPr/>
+        </p:nvSpPr>
+        <p:spPr>
+          <a:xfrm>
+            <a:off x="1645920" y="5440680"/>
+            <a:ext cx="8897112" cy="365760"/>
+          </a:xfrm>
+          <a:prstGeom prst="rect">
+            <a:avLst/>
+          </a:prstGeom>
+          <a:noFill/>
+          <a:ln/>
+        </p:spPr>
+        <p:txBody>
+          <a:bodyPr wrap="square" lIns="0" tIns="0" rIns="0" bIns="0" rtlCol="0" anchor="ctr"/>
+          <a:lstStyle/>
+          <a:p>
+            <a:pPr algn="ctr" indent="0" marL="0">
+              <a:buNone/>
+            </a:pPr>
+            <a:r>
+              <a:rPr lang="en-US" sz="1400" b="1" u="sng" dirty="0">
+                <a:solidFill>
+                  <a:srgbClr val="ECE2D0"/>
+                </a:solidFill>
+                <a:latin typeface="Calibri" pitchFamily="34" charset="0"/>
+                <a:ea typeface="Calibri" pitchFamily="34" charset="-122"/>
+                <a:cs typeface="Calibri" pitchFamily="34" charset="-120"/>
+                <a:hlinkClick r:id="rId2" invalidUrl="" action="" tgtFrame="" tooltip="" history="1" highlightClick="0" endSnd="0">
+                  <a:extLst>
+                    <a:ext uri="{A12FA001-AC4F-418D-AE19-62706E023703}">
+                      <ahyp:hlinkClr xmlns:ahyp="http://schemas.microsoft.com/office/drawing/2018/hyperlinkcolor" val="tx"/>
+                    </a:ext>
+                  </a:extLst>
+                </a:hlinkClick>
+              </a:rPr>
+              <a:t>github.com/satelesroberio/wine-quality-classification</a:t>
+            </a:r>
+            <a:endParaRPr lang="en-US" sz="1400" dirty="0"/>
+          </a:p>
+        </p:txBody>
+      </p:sp>
+      <p:sp>
+        <p:nvSpPr>
+          <p:cNvPr id="9" name="Text 6"/>
+          <p:cNvSpPr/>
+          <p:nvPr/>
+        </p:nvSpPr>
+        <p:spPr>
+          <a:xfrm>
+            <a:off x="1645920" y="6080760"/>
             <a:ext cx="8897112" cy="457200"/>
           </a:xfrm>
           <a:prstGeom prst="rect">

</xml_diff>

<commit_message>
Remove menção a piloto de produção do slide de próximos passos
</commit_message>
<xml_diff>
--- a/results/apresentacao_executiva.pptx
+++ b/results/apresentacao_executiva.pptx
@@ -1434,7 +1434,7 @@
           <a:p>
             <a:r>
               <a:rPr lang="en-US" dirty="0"/>
-              <a:t>Encerramento. Diga: 'Como próximos passos, propomos ampliar a base com novas safras, testar o modelo em um piloto real e ajustar os limiares com o retorno dos enólogos. O repositório completo está linkado no slide. Obrigado.'</a:t>
+              <a:t>Encerramento. Diga: 'Como próximos passos, propomos ampliar a base com novas safras e ajustar os limiares com o retorno dos enólogos. O repositório completo está linkado no slide. Obrigado.'</a:t>
             </a:r>
             <a:endParaRPr lang="en-US" dirty="0"/>
           </a:p>
@@ -2925,7 +2925,7 @@
                 <a:ea typeface="Calibri" pitchFamily="34" charset="-122"/>
                 <a:cs typeface="Calibri" pitchFamily="34" charset="-120"/>
               </a:rPr>
-              <a:t>Ampliar a base com novas safras  •  testar o modelo em um piloto real de produção  •  revisar limiares de decisão com o retorno dos enólogos</a:t>
+              <a:t>Ampliar a base com novas safras  •  revisar limiares de decisão com o retorno dos enólogos</a:t>
             </a:r>
             <a:endParaRPr lang="en-US" sz="1500" dirty="0"/>
           </a:p>

</xml_diff>

<commit_message>
Adiciona link do vídeo executivo na primeira página da apresentação
</commit_message>
<xml_diff>
--- a/results/apresentacao_executiva.pptx
+++ b/results/apresentacao_executiva.pptx
@@ -2679,14 +2679,38 @@
       </p:sp>
       <p:sp>
         <p:nvSpPr>
-          <p:cNvPr id="8" name="Text 5"/>
-          <p:cNvSpPr/>
-          <p:nvPr/>
-        </p:nvSpPr>
-        <p:spPr>
-          <a:xfrm>
-            <a:off x="1371600" y="5943600"/>
-            <a:ext cx="9445752" cy="365760"/>
+          <p:cNvPr id="8" name="Shape 5"/>
+          <p:cNvSpPr/>
+          <p:nvPr/>
+        </p:nvSpPr>
+        <p:spPr>
+          <a:xfrm>
+            <a:off x="4270248" y="4709160"/>
+            <a:ext cx="3657600" cy="457200"/>
+          </a:xfrm>
+          <a:prstGeom prst="roundRect">
+            <a:avLst>
+              <a:gd name="adj" fmla="val 50000"/>
+            </a:avLst>
+          </a:prstGeom>
+          <a:solidFill>
+            <a:srgbClr val="A26769"/>
+          </a:solidFill>
+          <a:ln/>
+        </p:spPr>
+      </p:sp>
+      <p:sp>
+        <p:nvSpPr>
+          <p:cNvPr id="9" name="Text 6">
+            <a:hlinkClick r:id="rId2" tooltip=""/>
+          </p:cNvPr>
+          <p:cNvSpPr/>
+          <p:nvPr/>
+        </p:nvSpPr>
+        <p:spPr>
+          <a:xfrm>
+            <a:off x="4270248" y="4709160"/>
+            <a:ext cx="3657600" cy="457200"/>
           </a:xfrm>
           <a:prstGeom prst="rect">
             <a:avLst/>
@@ -2702,13 +2726,59 @@
               <a:buNone/>
             </a:pPr>
             <a:r>
-              <a:rPr lang="en-US" sz="1200" dirty="0">
-                <a:solidFill>
-                  <a:srgbClr val="ECE2D0"/>
+              <a:rPr lang="en-US" sz="1300" b="1" u="sng" dirty="0">
+                <a:solidFill>
+                  <a:srgbClr val="FFFFFF"/>
                 </a:solidFill>
                 <a:latin typeface="Calibri" pitchFamily="34" charset="0"/>
                 <a:ea typeface="Calibri" pitchFamily="34" charset="-122"/>
                 <a:cs typeface="Calibri" pitchFamily="34" charset="-120"/>
+                <a:hlinkClick r:id="rId2" invalidUrl="" action="" tgtFrame="" tooltip="" history="1" highlightClick="0" endSnd="0">
+                  <a:extLst>
+                    <a:ext uri="{A12FA001-AC4F-418D-AE19-62706E023703}">
+                      <ahyp:hlinkClr xmlns:ahyp="http://schemas.microsoft.com/office/drawing/2018/hyperlinkcolor" val="tx"/>
+                    </a:ext>
+                  </a:extLst>
+                </a:hlinkClick>
+              </a:rPr>
+              <a:t>▶  Assista ao vídeo executivo</a:t>
+            </a:r>
+            <a:endParaRPr lang="en-US" sz="1300" dirty="0"/>
+          </a:p>
+        </p:txBody>
+      </p:sp>
+      <p:sp>
+        <p:nvSpPr>
+          <p:cNvPr id="10" name="Text 7"/>
+          <p:cNvSpPr/>
+          <p:nvPr/>
+        </p:nvSpPr>
+        <p:spPr>
+          <a:xfrm>
+            <a:off x="1371600" y="5943600"/>
+            <a:ext cx="9445752" cy="365760"/>
+          </a:xfrm>
+          <a:prstGeom prst="rect">
+            <a:avLst/>
+          </a:prstGeom>
+          <a:noFill/>
+          <a:ln/>
+        </p:spPr>
+        <p:txBody>
+          <a:bodyPr wrap="square" lIns="0" tIns="0" rIns="0" bIns="0" rtlCol="0" anchor="ctr"/>
+          <a:lstStyle/>
+          <a:p>
+            <a:pPr algn="ctr" indent="0" marL="0">
+              <a:buNone/>
+            </a:pPr>
+            <a:r>
+              <a:rPr lang="en-US" sz="1200" dirty="0">
+                <a:solidFill>
+                  <a:srgbClr val="ECE2D0"/>
+                </a:solidFill>
+                <a:latin typeface="Calibri" pitchFamily="34" charset="0"/>
+                <a:ea typeface="Calibri" pitchFamily="34" charset="-122"/>
+                <a:cs typeface="Calibri" pitchFamily="34" charset="-120"/>
               </a:rPr>
               <a:t>POSTECH  |  Tech Challenge Fase 2  -  Data Analytics</a:t>
             </a:r>
@@ -2718,7 +2788,7 @@
       </p:sp>
       <p:sp>
         <p:nvSpPr>
-          <p:cNvPr id="9" name="Text 6"/>
+          <p:cNvPr id="11" name="Text 8"/>
           <p:cNvSpPr/>
           <p:nvPr/>
         </p:nvSpPr>

</xml_diff>

<commit_message>
Usa link direto de download do vídeo e adiciona o link completo no slide final
</commit_message>
<xml_diff>
--- a/results/apresentacao_executiva.pptx
+++ b/results/apresentacao_executiva.pptx
@@ -2970,8 +2970,8 @@
         </p:nvSpPr>
         <p:spPr>
           <a:xfrm>
-            <a:off x="1645920" y="3291840"/>
-            <a:ext cx="8897112" cy="822960"/>
+            <a:off x="1645920" y="3383280"/>
+            <a:ext cx="8897112" cy="457200"/>
           </a:xfrm>
           <a:prstGeom prst="rect">
             <a:avLst/>
@@ -3009,8 +3009,8 @@
         </p:nvSpPr>
         <p:spPr>
           <a:xfrm>
-            <a:off x="1645920" y="5074920"/>
-            <a:ext cx="8897112" cy="365760"/>
+            <a:off x="1645920" y="4297680"/>
+            <a:ext cx="8897112" cy="320040"/>
           </a:xfrm>
           <a:prstGeom prst="rect">
             <a:avLst/>
@@ -3026,7 +3026,7 @@
               <a:buNone/>
             </a:pPr>
             <a:r>
-              <a:rPr lang="en-US" sz="1250" i="1" dirty="0">
+              <a:rPr lang="en-US" sz="1200" i="1" dirty="0">
                 <a:solidFill>
                   <a:srgbClr val="D8C7BE"/>
                 </a:solidFill>
@@ -3036,7 +3036,7 @@
               </a:rPr>
               <a:t>Código, notebooks e detalhamento técnico completo no repositório do projeto:</a:t>
             </a:r>
-            <a:endParaRPr lang="en-US" sz="1250" dirty="0"/>
+            <a:endParaRPr lang="en-US" sz="1200" dirty="0"/>
           </a:p>
         </p:txBody>
       </p:sp>
@@ -3050,8 +3050,8 @@
         </p:nvSpPr>
         <p:spPr>
           <a:xfrm>
-            <a:off x="1645920" y="5440680"/>
-            <a:ext cx="8897112" cy="365760"/>
+            <a:off x="1645920" y="4617720"/>
+            <a:ext cx="8897112" cy="320040"/>
           </a:xfrm>
           <a:prstGeom prst="rect">
             <a:avLst/>
@@ -3067,7 +3067,7 @@
               <a:buNone/>
             </a:pPr>
             <a:r>
-              <a:rPr lang="en-US" sz="1400" b="1" u="sng" dirty="0">
+              <a:rPr lang="en-US" sz="1350" b="1" u="sng" dirty="0">
                 <a:solidFill>
                   <a:srgbClr val="ECE2D0"/>
                 </a:solidFill>
@@ -3084,7 +3084,7 @@
               </a:rPr>
               <a:t>github.com/satelesroberio/wine-quality-classification</a:t>
             </a:r>
-            <a:endParaRPr lang="en-US" sz="1400" dirty="0"/>
+            <a:endParaRPr lang="en-US" sz="1350" dirty="0"/>
           </a:p>
         </p:txBody>
       </p:sp>
@@ -3096,8 +3096,8 @@
         </p:nvSpPr>
         <p:spPr>
           <a:xfrm>
-            <a:off x="1645920" y="6080760"/>
-            <a:ext cx="8897112" cy="457200"/>
+            <a:off x="1645920" y="5074920"/>
+            <a:ext cx="8897112" cy="320040"/>
           </a:xfrm>
           <a:prstGeom prst="rect">
             <a:avLst/>
@@ -3113,7 +3113,94 @@
               <a:buNone/>
             </a:pPr>
             <a:r>
-              <a:rPr lang="en-US" sz="1600" dirty="0">
+              <a:rPr lang="en-US" sz="1200" i="1" dirty="0">
+                <a:solidFill>
+                  <a:srgbClr val="D8C7BE"/>
+                </a:solidFill>
+                <a:latin typeface="Calibri" pitchFamily="34" charset="0"/>
+                <a:ea typeface="Calibri" pitchFamily="34" charset="-122"/>
+                <a:cs typeface="Calibri" pitchFamily="34" charset="-120"/>
+              </a:rPr>
+              <a:t>Vídeo executivo (link direto para download):</a:t>
+            </a:r>
+            <a:endParaRPr lang="en-US" sz="1200" dirty="0"/>
+          </a:p>
+        </p:txBody>
+      </p:sp>
+      <p:sp>
+        <p:nvSpPr>
+          <p:cNvPr id="10" name="Text 7">
+            <a:hlinkClick r:id="rId3" tooltip=""/>
+          </p:cNvPr>
+          <p:cNvSpPr/>
+          <p:nvPr/>
+        </p:nvSpPr>
+        <p:spPr>
+          <a:xfrm>
+            <a:off x="1280160" y="5394960"/>
+            <a:ext cx="9628632" cy="548640"/>
+          </a:xfrm>
+          <a:prstGeom prst="rect">
+            <a:avLst/>
+          </a:prstGeom>
+          <a:noFill/>
+          <a:ln/>
+        </p:spPr>
+        <p:txBody>
+          <a:bodyPr wrap="square" lIns="0" tIns="0" rIns="0" bIns="0" rtlCol="0" anchor="ctr"/>
+          <a:lstStyle/>
+          <a:p>
+            <a:pPr algn="ctr" indent="0" marL="0">
+              <a:buNone/>
+            </a:pPr>
+            <a:r>
+              <a:rPr lang="en-US" sz="1200" b="1" u="sng" dirty="0">
+                <a:solidFill>
+                  <a:srgbClr val="ECE2D0"/>
+                </a:solidFill>
+                <a:latin typeface="Calibri" pitchFamily="34" charset="0"/>
+                <a:ea typeface="Calibri" pitchFamily="34" charset="-122"/>
+                <a:cs typeface="Calibri" pitchFamily="34" charset="-120"/>
+                <a:hlinkClick r:id="rId3" invalidUrl="" action="" tgtFrame="" tooltip="" history="1" highlightClick="0" endSnd="0">
+                  <a:extLst>
+                    <a:ext uri="{A12FA001-AC4F-418D-AE19-62706E023703}">
+                      <ahyp:hlinkClr xmlns:ahyp="http://schemas.microsoft.com/office/drawing/2018/hyperlinkcolor" val="tx"/>
+                    </a:ext>
+                  </a:extLst>
+                </a:hlinkClick>
+              </a:rPr>
+              <a:t>github.com/satelesroberio/wine-quality-classification/raw/main/results/video_executivo.mp4</a:t>
+            </a:r>
+            <a:endParaRPr lang="en-US" sz="1200" dirty="0"/>
+          </a:p>
+        </p:txBody>
+      </p:sp>
+      <p:sp>
+        <p:nvSpPr>
+          <p:cNvPr id="11" name="Text 8"/>
+          <p:cNvSpPr/>
+          <p:nvPr/>
+        </p:nvSpPr>
+        <p:spPr>
+          <a:xfrm>
+            <a:off x="1645920" y="6217920"/>
+            <a:ext cx="8897112" cy="365760"/>
+          </a:xfrm>
+          <a:prstGeom prst="rect">
+            <a:avLst/>
+          </a:prstGeom>
+          <a:noFill/>
+          <a:ln/>
+        </p:spPr>
+        <p:txBody>
+          <a:bodyPr wrap="square" lIns="0" tIns="0" rIns="0" bIns="0" rtlCol="0" anchor="ctr"/>
+          <a:lstStyle/>
+          <a:p>
+            <a:pPr algn="ctr" indent="0" marL="0">
+              <a:buNone/>
+            </a:pPr>
+            <a:r>
+              <a:rPr lang="en-US" sz="1500" dirty="0">
                 <a:solidFill>
                   <a:srgbClr val="FFFFFF"/>
                 </a:solidFill>
@@ -3123,7 +3210,7 @@
               </a:rPr>
               <a:t>Obrigado.</a:t>
             </a:r>
-            <a:endParaRPr lang="en-US" sz="1600" dirty="0"/>
+            <a:endParaRPr lang="en-US" sz="1500" dirty="0"/>
           </a:p>
         </p:txBody>
       </p:sp>

</xml_diff>

<commit_message>
Substitui botão por link direto do vídeo na primeira página
</commit_message>
<xml_diff>
--- a/results/apresentacao_executiva.pptx
+++ b/results/apresentacao_executiva.pptx
@@ -2679,29 +2679,7 @@
       </p:sp>
       <p:sp>
         <p:nvSpPr>
-          <p:cNvPr id="8" name="Shape 5"/>
-          <p:cNvSpPr/>
-          <p:nvPr/>
-        </p:nvSpPr>
-        <p:spPr>
-          <a:xfrm>
-            <a:off x="4270248" y="4709160"/>
-            <a:ext cx="3657600" cy="457200"/>
-          </a:xfrm>
-          <a:prstGeom prst="roundRect">
-            <a:avLst>
-              <a:gd name="adj" fmla="val 50000"/>
-            </a:avLst>
-          </a:prstGeom>
-          <a:solidFill>
-            <a:srgbClr val="A26769"/>
-          </a:solidFill>
-          <a:ln/>
-        </p:spPr>
-      </p:sp>
-      <p:sp>
-        <p:nvSpPr>
-          <p:cNvPr id="9" name="Text 6">
+          <p:cNvPr id="8" name="Text 5">
             <a:hlinkClick r:id="rId2" tooltip=""/>
           </p:cNvPr>
           <p:cNvSpPr/>
@@ -2709,8 +2687,8 @@
         </p:nvSpPr>
         <p:spPr>
           <a:xfrm>
-            <a:off x="4270248" y="4709160"/>
-            <a:ext cx="3657600" cy="457200"/>
+            <a:off x="1280160" y="4754880"/>
+            <a:ext cx="9628632" cy="457200"/>
           </a:xfrm>
           <a:prstGeom prst="rect">
             <a:avLst/>
@@ -2726,9 +2704,9 @@
               <a:buNone/>
             </a:pPr>
             <a:r>
-              <a:rPr lang="en-US" sz="1300" b="1" u="sng" dirty="0">
-                <a:solidFill>
-                  <a:srgbClr val="FFFFFF"/>
+              <a:rPr lang="en-US" sz="1200" b="1" u="sng" dirty="0">
+                <a:solidFill>
+                  <a:srgbClr val="ECE2D0"/>
                 </a:solidFill>
                 <a:latin typeface="Calibri" pitchFamily="34" charset="0"/>
                 <a:ea typeface="Calibri" pitchFamily="34" charset="-122"/>
@@ -2741,15 +2719,15 @@
                   </a:extLst>
                 </a:hlinkClick>
               </a:rPr>
-              <a:t>▶  Assista ao vídeo executivo</a:t>
-            </a:r>
-            <a:endParaRPr lang="en-US" sz="1300" dirty="0"/>
-          </a:p>
-        </p:txBody>
-      </p:sp>
-      <p:sp>
-        <p:nvSpPr>
-          <p:cNvPr id="10" name="Text 7"/>
+              <a:t>github.com/satelesroberio/wine-quality-classification/raw/main/results/video_executivo.mp4</a:t>
+            </a:r>
+            <a:endParaRPr lang="en-US" sz="1200" dirty="0"/>
+          </a:p>
+        </p:txBody>
+      </p:sp>
+      <p:sp>
+        <p:nvSpPr>
+          <p:cNvPr id="9" name="Text 6"/>
           <p:cNvSpPr/>
           <p:nvPr/>
         </p:nvSpPr>
@@ -2788,7 +2766,7 @@
       </p:sp>
       <p:sp>
         <p:nvSpPr>
-          <p:cNvPr id="11" name="Text 8"/>
+          <p:cNvPr id="10" name="Text 7"/>
           <p:cNvSpPr/>
           <p:nvPr/>
         </p:nvSpPr>

</xml_diff>